<commit_message>
trading bot can now be run from ui
</commit_message>
<xml_diff>
--- a/BestModel.pptx
+++ b/BestModel.pptx
@@ -7,6 +7,16 @@
   <p:sldIdLst>
     <p:sldId id="257" r:id="rId2"/>
     <p:sldId id="258" r:id="rId3"/>
+    <p:sldId id="268" r:id="rId4"/>
+    <p:sldId id="259" r:id="rId5"/>
+    <p:sldId id="260" r:id="rId6"/>
+    <p:sldId id="261" r:id="rId7"/>
+    <p:sldId id="262" r:id="rId8"/>
+    <p:sldId id="263" r:id="rId9"/>
+    <p:sldId id="264" r:id="rId10"/>
+    <p:sldId id="265" r:id="rId11"/>
+    <p:sldId id="266" r:id="rId12"/>
+    <p:sldId id="267" r:id="rId13"/>
   </p:sldIdLst>
   <p:sldSz cx="12192000" cy="6858000"/>
   <p:notesSz cx="6858000" cy="9144000"/>
@@ -262,7 +272,7 @@
           <a:p>
             <a:fld id="{B07D9F59-A237-49D3-9A4D-F64E5524C87A}" type="datetimeFigureOut">
               <a:rPr lang="de-DE" smtClean="0"/>
-              <a:t>13.03.2026</a:t>
+              <a:t>19.03.2026</a:t>
             </a:fld>
             <a:endParaRPr lang="de-DE"/>
           </a:p>
@@ -316,7 +326,7 @@
           <a:p>
             <a:fld id="{86F4CE1A-866A-4FE2-8EC7-602F6A0E4D36}" type="slidenum">
               <a:rPr lang="de-DE" smtClean="0"/>
-              <a:t>‹Nr.›</a:t>
+              <a:t>‹#›</a:t>
             </a:fld>
             <a:endParaRPr lang="de-DE"/>
           </a:p>
@@ -462,7 +472,7 @@
           <a:p>
             <a:fld id="{B07D9F59-A237-49D3-9A4D-F64E5524C87A}" type="datetimeFigureOut">
               <a:rPr lang="de-DE" smtClean="0"/>
-              <a:t>13.03.2026</a:t>
+              <a:t>19.03.2026</a:t>
             </a:fld>
             <a:endParaRPr lang="de-DE"/>
           </a:p>
@@ -516,7 +526,7 @@
           <a:p>
             <a:fld id="{86F4CE1A-866A-4FE2-8EC7-602F6A0E4D36}" type="slidenum">
               <a:rPr lang="de-DE" smtClean="0"/>
-              <a:t>‹Nr.›</a:t>
+              <a:t>‹#›</a:t>
             </a:fld>
             <a:endParaRPr lang="de-DE"/>
           </a:p>
@@ -672,7 +682,7 @@
           <a:p>
             <a:fld id="{B07D9F59-A237-49D3-9A4D-F64E5524C87A}" type="datetimeFigureOut">
               <a:rPr lang="de-DE" smtClean="0"/>
-              <a:t>13.03.2026</a:t>
+              <a:t>19.03.2026</a:t>
             </a:fld>
             <a:endParaRPr lang="de-DE"/>
           </a:p>
@@ -726,7 +736,7 @@
           <a:p>
             <a:fld id="{86F4CE1A-866A-4FE2-8EC7-602F6A0E4D36}" type="slidenum">
               <a:rPr lang="de-DE" smtClean="0"/>
-              <a:t>‹Nr.›</a:t>
+              <a:t>‹#›</a:t>
             </a:fld>
             <a:endParaRPr lang="de-DE"/>
           </a:p>
@@ -872,7 +882,7 @@
           <a:p>
             <a:fld id="{B07D9F59-A237-49D3-9A4D-F64E5524C87A}" type="datetimeFigureOut">
               <a:rPr lang="de-DE" smtClean="0"/>
-              <a:t>13.03.2026</a:t>
+              <a:t>19.03.2026</a:t>
             </a:fld>
             <a:endParaRPr lang="de-DE"/>
           </a:p>
@@ -926,7 +936,7 @@
           <a:p>
             <a:fld id="{86F4CE1A-866A-4FE2-8EC7-602F6A0E4D36}" type="slidenum">
               <a:rPr lang="de-DE" smtClean="0"/>
-              <a:t>‹Nr.›</a:t>
+              <a:t>‹#›</a:t>
             </a:fld>
             <a:endParaRPr lang="de-DE"/>
           </a:p>
@@ -1148,7 +1158,7 @@
           <a:p>
             <a:fld id="{B07D9F59-A237-49D3-9A4D-F64E5524C87A}" type="datetimeFigureOut">
               <a:rPr lang="de-DE" smtClean="0"/>
-              <a:t>13.03.2026</a:t>
+              <a:t>19.03.2026</a:t>
             </a:fld>
             <a:endParaRPr lang="de-DE"/>
           </a:p>
@@ -1202,7 +1212,7 @@
           <a:p>
             <a:fld id="{86F4CE1A-866A-4FE2-8EC7-602F6A0E4D36}" type="slidenum">
               <a:rPr lang="de-DE" smtClean="0"/>
-              <a:t>‹Nr.›</a:t>
+              <a:t>‹#›</a:t>
             </a:fld>
             <a:endParaRPr lang="de-DE"/>
           </a:p>
@@ -1416,7 +1426,7 @@
           <a:p>
             <a:fld id="{B07D9F59-A237-49D3-9A4D-F64E5524C87A}" type="datetimeFigureOut">
               <a:rPr lang="de-DE" smtClean="0"/>
-              <a:t>13.03.2026</a:t>
+              <a:t>19.03.2026</a:t>
             </a:fld>
             <a:endParaRPr lang="de-DE"/>
           </a:p>
@@ -1470,7 +1480,7 @@
           <a:p>
             <a:fld id="{86F4CE1A-866A-4FE2-8EC7-602F6A0E4D36}" type="slidenum">
               <a:rPr lang="de-DE" smtClean="0"/>
-              <a:t>‹Nr.›</a:t>
+              <a:t>‹#›</a:t>
             </a:fld>
             <a:endParaRPr lang="de-DE"/>
           </a:p>
@@ -1831,7 +1841,7 @@
           <a:p>
             <a:fld id="{B07D9F59-A237-49D3-9A4D-F64E5524C87A}" type="datetimeFigureOut">
               <a:rPr lang="de-DE" smtClean="0"/>
-              <a:t>13.03.2026</a:t>
+              <a:t>19.03.2026</a:t>
             </a:fld>
             <a:endParaRPr lang="de-DE"/>
           </a:p>
@@ -1885,7 +1895,7 @@
           <a:p>
             <a:fld id="{86F4CE1A-866A-4FE2-8EC7-602F6A0E4D36}" type="slidenum">
               <a:rPr lang="de-DE" smtClean="0"/>
-              <a:t>‹Nr.›</a:t>
+              <a:t>‹#›</a:t>
             </a:fld>
             <a:endParaRPr lang="de-DE"/>
           </a:p>
@@ -1973,7 +1983,7 @@
           <a:p>
             <a:fld id="{B07D9F59-A237-49D3-9A4D-F64E5524C87A}" type="datetimeFigureOut">
               <a:rPr lang="de-DE" smtClean="0"/>
-              <a:t>13.03.2026</a:t>
+              <a:t>19.03.2026</a:t>
             </a:fld>
             <a:endParaRPr lang="de-DE"/>
           </a:p>
@@ -2027,7 +2037,7 @@
           <a:p>
             <a:fld id="{86F4CE1A-866A-4FE2-8EC7-602F6A0E4D36}" type="slidenum">
               <a:rPr lang="de-DE" smtClean="0"/>
-              <a:t>‹Nr.›</a:t>
+              <a:t>‹#›</a:t>
             </a:fld>
             <a:endParaRPr lang="de-DE"/>
           </a:p>
@@ -2086,7 +2096,7 @@
           <a:p>
             <a:fld id="{B07D9F59-A237-49D3-9A4D-F64E5524C87A}" type="datetimeFigureOut">
               <a:rPr lang="de-DE" smtClean="0"/>
-              <a:t>13.03.2026</a:t>
+              <a:t>19.03.2026</a:t>
             </a:fld>
             <a:endParaRPr lang="de-DE"/>
           </a:p>
@@ -2140,7 +2150,7 @@
           <a:p>
             <a:fld id="{86F4CE1A-866A-4FE2-8EC7-602F6A0E4D36}" type="slidenum">
               <a:rPr lang="de-DE" smtClean="0"/>
-              <a:t>‹Nr.›</a:t>
+              <a:t>‹#›</a:t>
             </a:fld>
             <a:endParaRPr lang="de-DE"/>
           </a:p>
@@ -2399,7 +2409,7 @@
           <a:p>
             <a:fld id="{B07D9F59-A237-49D3-9A4D-F64E5524C87A}" type="datetimeFigureOut">
               <a:rPr lang="de-DE" smtClean="0"/>
-              <a:t>13.03.2026</a:t>
+              <a:t>19.03.2026</a:t>
             </a:fld>
             <a:endParaRPr lang="de-DE"/>
           </a:p>
@@ -2453,7 +2463,7 @@
           <a:p>
             <a:fld id="{86F4CE1A-866A-4FE2-8EC7-602F6A0E4D36}" type="slidenum">
               <a:rPr lang="de-DE" smtClean="0"/>
-              <a:t>‹Nr.›</a:t>
+              <a:t>‹#›</a:t>
             </a:fld>
             <a:endParaRPr lang="de-DE"/>
           </a:p>
@@ -2688,7 +2698,7 @@
           <a:p>
             <a:fld id="{B07D9F59-A237-49D3-9A4D-F64E5524C87A}" type="datetimeFigureOut">
               <a:rPr lang="de-DE" smtClean="0"/>
-              <a:t>13.03.2026</a:t>
+              <a:t>19.03.2026</a:t>
             </a:fld>
             <a:endParaRPr lang="de-DE"/>
           </a:p>
@@ -2742,7 +2752,7 @@
           <a:p>
             <a:fld id="{86F4CE1A-866A-4FE2-8EC7-602F6A0E4D36}" type="slidenum">
               <a:rPr lang="de-DE" smtClean="0"/>
-              <a:t>‹Nr.›</a:t>
+              <a:t>‹#›</a:t>
             </a:fld>
             <a:endParaRPr lang="de-DE"/>
           </a:p>
@@ -2931,7 +2941,7 @@
           <a:p>
             <a:fld id="{B07D9F59-A237-49D3-9A4D-F64E5524C87A}" type="datetimeFigureOut">
               <a:rPr lang="de-DE" smtClean="0"/>
-              <a:t>13.03.2026</a:t>
+              <a:t>19.03.2026</a:t>
             </a:fld>
             <a:endParaRPr lang="de-DE"/>
           </a:p>
@@ -3021,7 +3031,7 @@
           <a:p>
             <a:fld id="{86F4CE1A-866A-4FE2-8EC7-602F6A0E4D36}" type="slidenum">
               <a:rPr lang="de-DE" smtClean="0"/>
-              <a:t>‹Nr.›</a:t>
+              <a:t>‹#›</a:t>
             </a:fld>
             <a:endParaRPr lang="de-DE"/>
           </a:p>
@@ -3724,6 +3734,303 @@
 </p:sld>
 </file>
 
+<file path=ppt/slides/slide10.xml><?xml version="1.0" encoding="utf-8"?>
+<p:sld xmlns:a="http://schemas.openxmlformats.org/drawingml/2006/main" xmlns:r="http://schemas.openxmlformats.org/officeDocument/2006/relationships" xmlns:p="http://schemas.openxmlformats.org/presentationml/2006/main">
+  <p:cSld>
+    <p:spTree>
+      <p:nvGrpSpPr>
+        <p:cNvPr id="1" name="">
+          <a:extLst>
+            <a:ext uri="{FF2B5EF4-FFF2-40B4-BE49-F238E27FC236}">
+              <a16:creationId xmlns:a16="http://schemas.microsoft.com/office/drawing/2014/main" id="{28CB339F-35D7-C679-E0E5-533618696F29}"/>
+            </a:ext>
+          </a:extLst>
+        </p:cNvPr>
+        <p:cNvGrpSpPr/>
+        <p:nvPr/>
+      </p:nvGrpSpPr>
+      <p:grpSpPr>
+        <a:xfrm>
+          <a:off x="0" y="0"/>
+          <a:ext cx="0" cy="0"/>
+          <a:chOff x="0" y="0"/>
+          <a:chExt cx="0" cy="0"/>
+        </a:xfrm>
+      </p:grpSpPr>
+      <p:sp>
+        <p:nvSpPr>
+          <p:cNvPr id="2" name="Title 1">
+            <a:extLst>
+              <a:ext uri="{FF2B5EF4-FFF2-40B4-BE49-F238E27FC236}">
+                <a16:creationId xmlns:a16="http://schemas.microsoft.com/office/drawing/2014/main" id="{51C01BBF-9D6D-87A1-A5EF-79DFFC59C7FC}"/>
+              </a:ext>
+            </a:extLst>
+          </p:cNvPr>
+          <p:cNvSpPr>
+            <a:spLocks noGrp="1"/>
+          </p:cNvSpPr>
+          <p:nvPr>
+            <p:ph type="title"/>
+          </p:nvPr>
+        </p:nvSpPr>
+        <p:spPr/>
+        <p:txBody>
+          <a:bodyPr>
+            <a:normAutofit/>
+          </a:bodyPr>
+          <a:lstStyle/>
+          <a:p>
+            <a:r>
+              <a:rPr lang="en-US" sz="2000" dirty="0"/>
+              <a:t>2026-03-16_MINI_BTCUSDT_1h_2021-01-01_2025-12-01_LB400_PRED12_BATCH64</a:t>
+            </a:r>
+            <a:endParaRPr lang="en-AT" sz="2000" dirty="0"/>
+          </a:p>
+        </p:txBody>
+      </p:sp>
+      <p:pic>
+        <p:nvPicPr>
+          <p:cNvPr id="7" name="Content Placeholder 6">
+            <a:extLst>
+              <a:ext uri="{FF2B5EF4-FFF2-40B4-BE49-F238E27FC236}">
+                <a16:creationId xmlns:a16="http://schemas.microsoft.com/office/drawing/2014/main" id="{64CD47A1-1D17-0B2E-DC51-478DC0850792}"/>
+              </a:ext>
+            </a:extLst>
+          </p:cNvPr>
+          <p:cNvPicPr>
+            <a:picLocks noGrp="1" noChangeAspect="1"/>
+          </p:cNvPicPr>
+          <p:nvPr>
+            <p:ph idx="1"/>
+          </p:nvPr>
+        </p:nvPicPr>
+        <p:blipFill>
+          <a:blip r:embed="rId2"/>
+          <a:stretch>
+            <a:fillRect/>
+          </a:stretch>
+        </p:blipFill>
+        <p:spPr>
+          <a:xfrm>
+            <a:off x="838200" y="2286639"/>
+            <a:ext cx="10515600" cy="3429309"/>
+          </a:xfrm>
+          <a:prstGeom prst="rect">
+            <a:avLst/>
+          </a:prstGeom>
+        </p:spPr>
+      </p:pic>
+    </p:spTree>
+    <p:extLst>
+      <p:ext uri="{BB962C8B-B14F-4D97-AF65-F5344CB8AC3E}">
+        <p14:creationId xmlns:p14="http://schemas.microsoft.com/office/powerpoint/2010/main" val="2776232474"/>
+      </p:ext>
+    </p:extLst>
+  </p:cSld>
+  <p:clrMapOvr>
+    <a:masterClrMapping/>
+  </p:clrMapOvr>
+</p:sld>
+</file>
+
+<file path=ppt/slides/slide11.xml><?xml version="1.0" encoding="utf-8"?>
+<p:sld xmlns:a="http://schemas.openxmlformats.org/drawingml/2006/main" xmlns:r="http://schemas.openxmlformats.org/officeDocument/2006/relationships" xmlns:p="http://schemas.openxmlformats.org/presentationml/2006/main">
+  <p:cSld>
+    <p:spTree>
+      <p:nvGrpSpPr>
+        <p:cNvPr id="1" name="">
+          <a:extLst>
+            <a:ext uri="{FF2B5EF4-FFF2-40B4-BE49-F238E27FC236}">
+              <a16:creationId xmlns:a16="http://schemas.microsoft.com/office/drawing/2014/main" id="{67469A42-12BA-F21A-BC7E-C323CC17AF90}"/>
+            </a:ext>
+          </a:extLst>
+        </p:cNvPr>
+        <p:cNvGrpSpPr/>
+        <p:nvPr/>
+      </p:nvGrpSpPr>
+      <p:grpSpPr>
+        <a:xfrm>
+          <a:off x="0" y="0"/>
+          <a:ext cx="0" cy="0"/>
+          <a:chOff x="0" y="0"/>
+          <a:chExt cx="0" cy="0"/>
+        </a:xfrm>
+      </p:grpSpPr>
+      <p:sp>
+        <p:nvSpPr>
+          <p:cNvPr id="2" name="Title 1">
+            <a:extLst>
+              <a:ext uri="{FF2B5EF4-FFF2-40B4-BE49-F238E27FC236}">
+                <a16:creationId xmlns:a16="http://schemas.microsoft.com/office/drawing/2014/main" id="{285842FB-4800-03D9-44E2-3F2AE79446F2}"/>
+              </a:ext>
+            </a:extLst>
+          </p:cNvPr>
+          <p:cNvSpPr>
+            <a:spLocks noGrp="1"/>
+          </p:cNvSpPr>
+          <p:nvPr>
+            <p:ph type="title"/>
+          </p:nvPr>
+        </p:nvSpPr>
+        <p:spPr/>
+        <p:txBody>
+          <a:bodyPr>
+            <a:normAutofit/>
+          </a:bodyPr>
+          <a:lstStyle/>
+          <a:p>
+            <a:r>
+              <a:rPr lang="en-US" sz="2000" dirty="0"/>
+              <a:t>2026-03-14_SMALL_BTCUSDT_1h_2024-01-01_2026-01-14_LB512_PRED12</a:t>
+            </a:r>
+            <a:endParaRPr lang="en-AT" sz="2000" dirty="0"/>
+          </a:p>
+        </p:txBody>
+      </p:sp>
+      <p:pic>
+        <p:nvPicPr>
+          <p:cNvPr id="6" name="Content Placeholder 5">
+            <a:extLst>
+              <a:ext uri="{FF2B5EF4-FFF2-40B4-BE49-F238E27FC236}">
+                <a16:creationId xmlns:a16="http://schemas.microsoft.com/office/drawing/2014/main" id="{9D774158-6D17-2D2A-0832-D3A044974987}"/>
+              </a:ext>
+            </a:extLst>
+          </p:cNvPr>
+          <p:cNvPicPr>
+            <a:picLocks noGrp="1" noChangeAspect="1"/>
+          </p:cNvPicPr>
+          <p:nvPr>
+            <p:ph idx="1"/>
+          </p:nvPr>
+        </p:nvPicPr>
+        <p:blipFill>
+          <a:blip r:embed="rId2"/>
+          <a:stretch>
+            <a:fillRect/>
+          </a:stretch>
+        </p:blipFill>
+        <p:spPr>
+          <a:xfrm>
+            <a:off x="838200" y="2293754"/>
+            <a:ext cx="10515600" cy="3415079"/>
+          </a:xfrm>
+          <a:prstGeom prst="rect">
+            <a:avLst/>
+          </a:prstGeom>
+        </p:spPr>
+      </p:pic>
+    </p:spTree>
+    <p:extLst>
+      <p:ext uri="{BB962C8B-B14F-4D97-AF65-F5344CB8AC3E}">
+        <p14:creationId xmlns:p14="http://schemas.microsoft.com/office/powerpoint/2010/main" val="3033166392"/>
+      </p:ext>
+    </p:extLst>
+  </p:cSld>
+  <p:clrMapOvr>
+    <a:masterClrMapping/>
+  </p:clrMapOvr>
+</p:sld>
+</file>
+
+<file path=ppt/slides/slide12.xml><?xml version="1.0" encoding="utf-8"?>
+<p:sld xmlns:a="http://schemas.openxmlformats.org/drawingml/2006/main" xmlns:r="http://schemas.openxmlformats.org/officeDocument/2006/relationships" xmlns:p="http://schemas.openxmlformats.org/presentationml/2006/main">
+  <p:cSld>
+    <p:spTree>
+      <p:nvGrpSpPr>
+        <p:cNvPr id="1" name="">
+          <a:extLst>
+            <a:ext uri="{FF2B5EF4-FFF2-40B4-BE49-F238E27FC236}">
+              <a16:creationId xmlns:a16="http://schemas.microsoft.com/office/drawing/2014/main" id="{85C97AB6-A701-2643-B6F7-2BE7DE8AD3F5}"/>
+            </a:ext>
+          </a:extLst>
+        </p:cNvPr>
+        <p:cNvGrpSpPr/>
+        <p:nvPr/>
+      </p:nvGrpSpPr>
+      <p:grpSpPr>
+        <a:xfrm>
+          <a:off x="0" y="0"/>
+          <a:ext cx="0" cy="0"/>
+          <a:chOff x="0" y="0"/>
+          <a:chExt cx="0" cy="0"/>
+        </a:xfrm>
+      </p:grpSpPr>
+      <p:sp>
+        <p:nvSpPr>
+          <p:cNvPr id="2" name="Title 1">
+            <a:extLst>
+              <a:ext uri="{FF2B5EF4-FFF2-40B4-BE49-F238E27FC236}">
+                <a16:creationId xmlns:a16="http://schemas.microsoft.com/office/drawing/2014/main" id="{33662718-A9AF-2360-72A3-E102096E74D0}"/>
+              </a:ext>
+            </a:extLst>
+          </p:cNvPr>
+          <p:cNvSpPr>
+            <a:spLocks noGrp="1"/>
+          </p:cNvSpPr>
+          <p:nvPr>
+            <p:ph type="title"/>
+          </p:nvPr>
+        </p:nvSpPr>
+        <p:spPr/>
+        <p:txBody>
+          <a:bodyPr>
+            <a:normAutofit/>
+          </a:bodyPr>
+          <a:lstStyle/>
+          <a:p>
+            <a:r>
+              <a:rPr lang="pt-BR" sz="2000" dirty="0"/>
+              <a:t>2026-03-13_BASE_BTCUSDT_1h_2021-01-01_2025-12-01_LB512_PRED12</a:t>
+            </a:r>
+            <a:endParaRPr lang="en-AT" sz="2000" dirty="0"/>
+          </a:p>
+        </p:txBody>
+      </p:sp>
+      <p:pic>
+        <p:nvPicPr>
+          <p:cNvPr id="7" name="Content Placeholder 6">
+            <a:extLst>
+              <a:ext uri="{FF2B5EF4-FFF2-40B4-BE49-F238E27FC236}">
+                <a16:creationId xmlns:a16="http://schemas.microsoft.com/office/drawing/2014/main" id="{6FBA6B1C-95B3-1356-EF01-EE9EF6D5E262}"/>
+              </a:ext>
+            </a:extLst>
+          </p:cNvPr>
+          <p:cNvPicPr>
+            <a:picLocks noGrp="1" noChangeAspect="1"/>
+          </p:cNvPicPr>
+          <p:nvPr>
+            <p:ph idx="1"/>
+          </p:nvPr>
+        </p:nvPicPr>
+        <p:blipFill>
+          <a:blip r:embed="rId2"/>
+          <a:stretch>
+            <a:fillRect/>
+          </a:stretch>
+        </p:blipFill>
+        <p:spPr>
+          <a:xfrm>
+            <a:off x="838200" y="2294909"/>
+            <a:ext cx="10515600" cy="3412770"/>
+          </a:xfrm>
+          <a:prstGeom prst="rect">
+            <a:avLst/>
+          </a:prstGeom>
+        </p:spPr>
+      </p:pic>
+    </p:spTree>
+    <p:extLst>
+      <p:ext uri="{BB962C8B-B14F-4D97-AF65-F5344CB8AC3E}">
+        <p14:creationId xmlns:p14="http://schemas.microsoft.com/office/powerpoint/2010/main" val="2880190361"/>
+      </p:ext>
+    </p:extLst>
+  </p:cSld>
+  <p:clrMapOvr>
+    <a:masterClrMapping/>
+  </p:clrMapOvr>
+</p:sld>
+</file>
+
 <file path=ppt/slides/slide2.xml><?xml version="1.0" encoding="utf-8"?>
 <p:sld xmlns:a="http://schemas.openxmlformats.org/drawingml/2006/main" xmlns:r="http://schemas.openxmlformats.org/officeDocument/2006/relationships" xmlns:p="http://schemas.openxmlformats.org/presentationml/2006/main">
   <p:cSld>
@@ -4065,6 +4372,687 @@
     <p:extLst>
       <p:ext uri="{BB962C8B-B14F-4D97-AF65-F5344CB8AC3E}">
         <p14:creationId xmlns:p14="http://schemas.microsoft.com/office/powerpoint/2010/main" val="2717360456"/>
+      </p:ext>
+    </p:extLst>
+  </p:cSld>
+  <p:clrMapOvr>
+    <a:masterClrMapping/>
+  </p:clrMapOvr>
+</p:sld>
+</file>
+
+<file path=ppt/slides/slide3.xml><?xml version="1.0" encoding="utf-8"?>
+<p:sld xmlns:a="http://schemas.openxmlformats.org/drawingml/2006/main" xmlns:r="http://schemas.openxmlformats.org/officeDocument/2006/relationships" xmlns:p="http://schemas.openxmlformats.org/presentationml/2006/main">
+  <p:cSld>
+    <p:spTree>
+      <p:nvGrpSpPr>
+        <p:cNvPr id="1" name=""/>
+        <p:cNvGrpSpPr/>
+        <p:nvPr/>
+      </p:nvGrpSpPr>
+      <p:grpSpPr>
+        <a:xfrm>
+          <a:off x="0" y="0"/>
+          <a:ext cx="0" cy="0"/>
+          <a:chOff x="0" y="0"/>
+          <a:chExt cx="0" cy="0"/>
+        </a:xfrm>
+      </p:grpSpPr>
+      <p:sp>
+        <p:nvSpPr>
+          <p:cNvPr id="2" name="Title 1">
+            <a:extLst>
+              <a:ext uri="{FF2B5EF4-FFF2-40B4-BE49-F238E27FC236}">
+                <a16:creationId xmlns:a16="http://schemas.microsoft.com/office/drawing/2014/main" id="{762C2D66-1639-D4D7-D197-913F917DF824}"/>
+              </a:ext>
+            </a:extLst>
+          </p:cNvPr>
+          <p:cNvSpPr>
+            <a:spLocks noGrp="1"/>
+          </p:cNvSpPr>
+          <p:nvPr>
+            <p:ph type="title"/>
+          </p:nvPr>
+        </p:nvSpPr>
+        <p:spPr/>
+        <p:txBody>
+          <a:bodyPr/>
+          <a:lstStyle/>
+          <a:p>
+            <a:endParaRPr lang="en-AT" dirty="0"/>
+          </a:p>
+        </p:txBody>
+      </p:sp>
+      <p:pic>
+        <p:nvPicPr>
+          <p:cNvPr id="5" name="Content Placeholder 4">
+            <a:extLst>
+              <a:ext uri="{FF2B5EF4-FFF2-40B4-BE49-F238E27FC236}">
+                <a16:creationId xmlns:a16="http://schemas.microsoft.com/office/drawing/2014/main" id="{189F86CC-647A-D21E-60BA-08A2965921BB}"/>
+              </a:ext>
+            </a:extLst>
+          </p:cNvPr>
+          <p:cNvPicPr>
+            <a:picLocks noGrp="1" noChangeAspect="1"/>
+          </p:cNvPicPr>
+          <p:nvPr>
+            <p:ph idx="1"/>
+          </p:nvPr>
+        </p:nvPicPr>
+        <p:blipFill>
+          <a:blip r:embed="rId2">
+            <a:extLst>
+              <a:ext uri="{28A0092B-C50C-407E-A947-70E740481C1C}">
+                <a14:useLocalDpi xmlns:a14="http://schemas.microsoft.com/office/drawing/2010/main" val="0"/>
+              </a:ext>
+            </a:extLst>
+          </a:blip>
+          <a:stretch>
+            <a:fillRect/>
+          </a:stretch>
+        </p:blipFill>
+        <p:spPr>
+          <a:xfrm>
+            <a:off x="874394" y="1825625"/>
+            <a:ext cx="10443211" cy="4351338"/>
+          </a:xfrm>
+          <a:prstGeom prst="rect">
+            <a:avLst/>
+          </a:prstGeom>
+        </p:spPr>
+      </p:pic>
+    </p:spTree>
+    <p:extLst>
+      <p:ext uri="{BB962C8B-B14F-4D97-AF65-F5344CB8AC3E}">
+        <p14:creationId xmlns:p14="http://schemas.microsoft.com/office/powerpoint/2010/main" val="220846660"/>
+      </p:ext>
+    </p:extLst>
+  </p:cSld>
+  <p:clrMapOvr>
+    <a:masterClrMapping/>
+  </p:clrMapOvr>
+</p:sld>
+</file>
+
+<file path=ppt/slides/slide4.xml><?xml version="1.0" encoding="utf-8"?>
+<p:sld xmlns:a="http://schemas.openxmlformats.org/drawingml/2006/main" xmlns:r="http://schemas.openxmlformats.org/officeDocument/2006/relationships" xmlns:p="http://schemas.openxmlformats.org/presentationml/2006/main">
+  <p:cSld>
+    <p:spTree>
+      <p:nvGrpSpPr>
+        <p:cNvPr id="1" name=""/>
+        <p:cNvGrpSpPr/>
+        <p:nvPr/>
+      </p:nvGrpSpPr>
+      <p:grpSpPr>
+        <a:xfrm>
+          <a:off x="0" y="0"/>
+          <a:ext cx="0" cy="0"/>
+          <a:chOff x="0" y="0"/>
+          <a:chExt cx="0" cy="0"/>
+        </a:xfrm>
+      </p:grpSpPr>
+      <p:sp>
+        <p:nvSpPr>
+          <p:cNvPr id="2" name="Title 1">
+            <a:extLst>
+              <a:ext uri="{FF2B5EF4-FFF2-40B4-BE49-F238E27FC236}">
+                <a16:creationId xmlns:a16="http://schemas.microsoft.com/office/drawing/2014/main" id="{0E4E3CA4-6709-C03A-E644-5C340D063C2D}"/>
+              </a:ext>
+            </a:extLst>
+          </p:cNvPr>
+          <p:cNvSpPr>
+            <a:spLocks noGrp="1"/>
+          </p:cNvSpPr>
+          <p:nvPr>
+            <p:ph type="title"/>
+          </p:nvPr>
+        </p:nvSpPr>
+        <p:spPr/>
+        <p:txBody>
+          <a:bodyPr>
+            <a:normAutofit/>
+          </a:bodyPr>
+          <a:lstStyle/>
+          <a:p>
+            <a:r>
+              <a:rPr lang="pt-BR" sz="2000" dirty="0"/>
+              <a:t>2026-03-19_MINI_BTCUSDT_1h_2021-01-01_2025-12-01_LB300_PRED12</a:t>
+            </a:r>
+            <a:endParaRPr lang="en-AT" sz="2000" dirty="0"/>
+          </a:p>
+        </p:txBody>
+      </p:sp>
+      <p:pic>
+        <p:nvPicPr>
+          <p:cNvPr id="7" name="Content Placeholder 6">
+            <a:extLst>
+              <a:ext uri="{FF2B5EF4-FFF2-40B4-BE49-F238E27FC236}">
+                <a16:creationId xmlns:a16="http://schemas.microsoft.com/office/drawing/2014/main" id="{A20F36B4-ADCE-C3FA-D859-20E2A58098F4}"/>
+              </a:ext>
+            </a:extLst>
+          </p:cNvPr>
+          <p:cNvPicPr>
+            <a:picLocks noGrp="1" noChangeAspect="1"/>
+          </p:cNvPicPr>
+          <p:nvPr>
+            <p:ph idx="1"/>
+          </p:nvPr>
+        </p:nvPicPr>
+        <p:blipFill>
+          <a:blip r:embed="rId2"/>
+          <a:stretch>
+            <a:fillRect/>
+          </a:stretch>
+        </p:blipFill>
+        <p:spPr>
+          <a:xfrm>
+            <a:off x="838200" y="2277019"/>
+            <a:ext cx="10515600" cy="3448550"/>
+          </a:xfrm>
+          <a:prstGeom prst="rect">
+            <a:avLst/>
+          </a:prstGeom>
+        </p:spPr>
+      </p:pic>
+    </p:spTree>
+    <p:extLst>
+      <p:ext uri="{BB962C8B-B14F-4D97-AF65-F5344CB8AC3E}">
+        <p14:creationId xmlns:p14="http://schemas.microsoft.com/office/powerpoint/2010/main" val="433882363"/>
+      </p:ext>
+    </p:extLst>
+  </p:cSld>
+  <p:clrMapOvr>
+    <a:masterClrMapping/>
+  </p:clrMapOvr>
+</p:sld>
+</file>
+
+<file path=ppt/slides/slide5.xml><?xml version="1.0" encoding="utf-8"?>
+<p:sld xmlns:a="http://schemas.openxmlformats.org/drawingml/2006/main" xmlns:r="http://schemas.openxmlformats.org/officeDocument/2006/relationships" xmlns:p="http://schemas.openxmlformats.org/presentationml/2006/main">
+  <p:cSld>
+    <p:spTree>
+      <p:nvGrpSpPr>
+        <p:cNvPr id="1" name="">
+          <a:extLst>
+            <a:ext uri="{FF2B5EF4-FFF2-40B4-BE49-F238E27FC236}">
+              <a16:creationId xmlns:a16="http://schemas.microsoft.com/office/drawing/2014/main" id="{C1F5B471-7A42-1FC6-D898-D5CC261F7004}"/>
+            </a:ext>
+          </a:extLst>
+        </p:cNvPr>
+        <p:cNvGrpSpPr/>
+        <p:nvPr/>
+      </p:nvGrpSpPr>
+      <p:grpSpPr>
+        <a:xfrm>
+          <a:off x="0" y="0"/>
+          <a:ext cx="0" cy="0"/>
+          <a:chOff x="0" y="0"/>
+          <a:chExt cx="0" cy="0"/>
+        </a:xfrm>
+      </p:grpSpPr>
+      <p:sp>
+        <p:nvSpPr>
+          <p:cNvPr id="2" name="Title 1">
+            <a:extLst>
+              <a:ext uri="{FF2B5EF4-FFF2-40B4-BE49-F238E27FC236}">
+                <a16:creationId xmlns:a16="http://schemas.microsoft.com/office/drawing/2014/main" id="{12DAB361-79A6-8827-83FC-54117BC8694F}"/>
+              </a:ext>
+            </a:extLst>
+          </p:cNvPr>
+          <p:cNvSpPr>
+            <a:spLocks noGrp="1"/>
+          </p:cNvSpPr>
+          <p:nvPr>
+            <p:ph type="title"/>
+          </p:nvPr>
+        </p:nvSpPr>
+        <p:spPr/>
+        <p:txBody>
+          <a:bodyPr>
+            <a:normAutofit/>
+          </a:bodyPr>
+          <a:lstStyle/>
+          <a:p>
+            <a:r>
+              <a:rPr lang="pt-BR" sz="2000" dirty="0"/>
+              <a:t>2026-03-13_MINI_BTCUSDT_1h_2021-01-01_2025-12-01_LB400_PRED12</a:t>
+            </a:r>
+            <a:endParaRPr lang="en-AT" sz="2000" dirty="0"/>
+          </a:p>
+        </p:txBody>
+      </p:sp>
+      <p:pic>
+        <p:nvPicPr>
+          <p:cNvPr id="9" name="Content Placeholder 8">
+            <a:extLst>
+              <a:ext uri="{FF2B5EF4-FFF2-40B4-BE49-F238E27FC236}">
+                <a16:creationId xmlns:a16="http://schemas.microsoft.com/office/drawing/2014/main" id="{62CF4730-55BA-1B81-2AE3-6FC08B74FEE1}"/>
+              </a:ext>
+            </a:extLst>
+          </p:cNvPr>
+          <p:cNvPicPr>
+            <a:picLocks noGrp="1" noChangeAspect="1"/>
+          </p:cNvPicPr>
+          <p:nvPr>
+            <p:ph idx="1"/>
+          </p:nvPr>
+        </p:nvPicPr>
+        <p:blipFill>
+          <a:blip r:embed="rId2"/>
+          <a:stretch>
+            <a:fillRect/>
+          </a:stretch>
+        </p:blipFill>
+        <p:spPr>
+          <a:xfrm>
+            <a:off x="838200" y="2279462"/>
+            <a:ext cx="10515600" cy="3443663"/>
+          </a:xfrm>
+          <a:prstGeom prst="rect">
+            <a:avLst/>
+          </a:prstGeom>
+        </p:spPr>
+      </p:pic>
+    </p:spTree>
+    <p:extLst>
+      <p:ext uri="{BB962C8B-B14F-4D97-AF65-F5344CB8AC3E}">
+        <p14:creationId xmlns:p14="http://schemas.microsoft.com/office/powerpoint/2010/main" val="1233097229"/>
+      </p:ext>
+    </p:extLst>
+  </p:cSld>
+  <p:clrMapOvr>
+    <a:masterClrMapping/>
+  </p:clrMapOvr>
+</p:sld>
+</file>
+
+<file path=ppt/slides/slide6.xml><?xml version="1.0" encoding="utf-8"?>
+<p:sld xmlns:a="http://schemas.openxmlformats.org/drawingml/2006/main" xmlns:r="http://schemas.openxmlformats.org/officeDocument/2006/relationships" xmlns:p="http://schemas.openxmlformats.org/presentationml/2006/main">
+  <p:cSld>
+    <p:spTree>
+      <p:nvGrpSpPr>
+        <p:cNvPr id="1" name="">
+          <a:extLst>
+            <a:ext uri="{FF2B5EF4-FFF2-40B4-BE49-F238E27FC236}">
+              <a16:creationId xmlns:a16="http://schemas.microsoft.com/office/drawing/2014/main" id="{AB9E7F22-305E-978F-B222-AF825E251654}"/>
+            </a:ext>
+          </a:extLst>
+        </p:cNvPr>
+        <p:cNvGrpSpPr/>
+        <p:nvPr/>
+      </p:nvGrpSpPr>
+      <p:grpSpPr>
+        <a:xfrm>
+          <a:off x="0" y="0"/>
+          <a:ext cx="0" cy="0"/>
+          <a:chOff x="0" y="0"/>
+          <a:chExt cx="0" cy="0"/>
+        </a:xfrm>
+      </p:grpSpPr>
+      <p:sp>
+        <p:nvSpPr>
+          <p:cNvPr id="2" name="Title 1">
+            <a:extLst>
+              <a:ext uri="{FF2B5EF4-FFF2-40B4-BE49-F238E27FC236}">
+                <a16:creationId xmlns:a16="http://schemas.microsoft.com/office/drawing/2014/main" id="{8FE3C938-0466-3A22-F962-34CC1AD9522D}"/>
+              </a:ext>
+            </a:extLst>
+          </p:cNvPr>
+          <p:cNvSpPr>
+            <a:spLocks noGrp="1"/>
+          </p:cNvSpPr>
+          <p:nvPr>
+            <p:ph type="title"/>
+          </p:nvPr>
+        </p:nvSpPr>
+        <p:spPr/>
+        <p:txBody>
+          <a:bodyPr>
+            <a:normAutofit/>
+          </a:bodyPr>
+          <a:lstStyle/>
+          <a:p>
+            <a:r>
+              <a:rPr lang="pt-BR" sz="2000" dirty="0"/>
+              <a:t>2026-03-15_MINI_BTCUSDT_1h_2021-01-01_2025-12-01_LB512_PRED12</a:t>
+            </a:r>
+            <a:endParaRPr lang="en-AT" sz="2000" dirty="0"/>
+          </a:p>
+        </p:txBody>
+      </p:sp>
+      <p:pic>
+        <p:nvPicPr>
+          <p:cNvPr id="8" name="Content Placeholder 7">
+            <a:extLst>
+              <a:ext uri="{FF2B5EF4-FFF2-40B4-BE49-F238E27FC236}">
+                <a16:creationId xmlns:a16="http://schemas.microsoft.com/office/drawing/2014/main" id="{F0BEC559-5648-8330-A7E8-13E0DA036BA4}"/>
+              </a:ext>
+            </a:extLst>
+          </p:cNvPr>
+          <p:cNvPicPr>
+            <a:picLocks noGrp="1" noChangeAspect="1"/>
+          </p:cNvPicPr>
+          <p:nvPr>
+            <p:ph idx="1"/>
+          </p:nvPr>
+        </p:nvPicPr>
+        <p:blipFill>
+          <a:blip r:embed="rId2"/>
+          <a:stretch>
+            <a:fillRect/>
+          </a:stretch>
+        </p:blipFill>
+        <p:spPr>
+          <a:xfrm>
+            <a:off x="838200" y="2278179"/>
+            <a:ext cx="10515600" cy="3446229"/>
+          </a:xfrm>
+          <a:prstGeom prst="rect">
+            <a:avLst/>
+          </a:prstGeom>
+        </p:spPr>
+      </p:pic>
+    </p:spTree>
+    <p:extLst>
+      <p:ext uri="{BB962C8B-B14F-4D97-AF65-F5344CB8AC3E}">
+        <p14:creationId xmlns:p14="http://schemas.microsoft.com/office/powerpoint/2010/main" val="3504275946"/>
+      </p:ext>
+    </p:extLst>
+  </p:cSld>
+  <p:clrMapOvr>
+    <a:masterClrMapping/>
+  </p:clrMapOvr>
+</p:sld>
+</file>
+
+<file path=ppt/slides/slide7.xml><?xml version="1.0" encoding="utf-8"?>
+<p:sld xmlns:a="http://schemas.openxmlformats.org/drawingml/2006/main" xmlns:r="http://schemas.openxmlformats.org/officeDocument/2006/relationships" xmlns:p="http://schemas.openxmlformats.org/presentationml/2006/main">
+  <p:cSld>
+    <p:spTree>
+      <p:nvGrpSpPr>
+        <p:cNvPr id="1" name="">
+          <a:extLst>
+            <a:ext uri="{FF2B5EF4-FFF2-40B4-BE49-F238E27FC236}">
+              <a16:creationId xmlns:a16="http://schemas.microsoft.com/office/drawing/2014/main" id="{36B797A3-66FE-4569-ED8D-C101BD654E8F}"/>
+            </a:ext>
+          </a:extLst>
+        </p:cNvPr>
+        <p:cNvGrpSpPr/>
+        <p:nvPr/>
+      </p:nvGrpSpPr>
+      <p:grpSpPr>
+        <a:xfrm>
+          <a:off x="0" y="0"/>
+          <a:ext cx="0" cy="0"/>
+          <a:chOff x="0" y="0"/>
+          <a:chExt cx="0" cy="0"/>
+        </a:xfrm>
+      </p:grpSpPr>
+      <p:sp>
+        <p:nvSpPr>
+          <p:cNvPr id="2" name="Title 1">
+            <a:extLst>
+              <a:ext uri="{FF2B5EF4-FFF2-40B4-BE49-F238E27FC236}">
+                <a16:creationId xmlns:a16="http://schemas.microsoft.com/office/drawing/2014/main" id="{3196DB0F-7A97-745F-45C3-4C5CC40724D3}"/>
+              </a:ext>
+            </a:extLst>
+          </p:cNvPr>
+          <p:cNvSpPr>
+            <a:spLocks noGrp="1"/>
+          </p:cNvSpPr>
+          <p:nvPr>
+            <p:ph type="title"/>
+          </p:nvPr>
+        </p:nvSpPr>
+        <p:spPr/>
+        <p:txBody>
+          <a:bodyPr>
+            <a:normAutofit/>
+          </a:bodyPr>
+          <a:lstStyle/>
+          <a:p>
+            <a:r>
+              <a:rPr lang="pt-BR" sz="2000" dirty="0"/>
+              <a:t>2026-03-15_MINI_BTCUSDT_1h_2021-01-01_2025-12-01_LB612_PRED12</a:t>
+            </a:r>
+            <a:endParaRPr lang="en-AT" sz="2000" dirty="0"/>
+          </a:p>
+        </p:txBody>
+      </p:sp>
+      <p:pic>
+        <p:nvPicPr>
+          <p:cNvPr id="6" name="Content Placeholder 5">
+            <a:extLst>
+              <a:ext uri="{FF2B5EF4-FFF2-40B4-BE49-F238E27FC236}">
+                <a16:creationId xmlns:a16="http://schemas.microsoft.com/office/drawing/2014/main" id="{37BB1C63-12E9-B6EB-6CC7-A74BC1C532B7}"/>
+              </a:ext>
+            </a:extLst>
+          </p:cNvPr>
+          <p:cNvPicPr>
+            <a:picLocks noGrp="1" noChangeAspect="1"/>
+          </p:cNvPicPr>
+          <p:nvPr>
+            <p:ph idx="1"/>
+          </p:nvPr>
+        </p:nvPicPr>
+        <p:blipFill>
+          <a:blip r:embed="rId2"/>
+          <a:stretch>
+            <a:fillRect/>
+          </a:stretch>
+        </p:blipFill>
+        <p:spPr>
+          <a:xfrm>
+            <a:off x="838200" y="2284100"/>
+            <a:ext cx="10515600" cy="3434388"/>
+          </a:xfrm>
+          <a:prstGeom prst="rect">
+            <a:avLst/>
+          </a:prstGeom>
+        </p:spPr>
+      </p:pic>
+    </p:spTree>
+    <p:extLst>
+      <p:ext uri="{BB962C8B-B14F-4D97-AF65-F5344CB8AC3E}">
+        <p14:creationId xmlns:p14="http://schemas.microsoft.com/office/powerpoint/2010/main" val="3570799388"/>
+      </p:ext>
+    </p:extLst>
+  </p:cSld>
+  <p:clrMapOvr>
+    <a:masterClrMapping/>
+  </p:clrMapOvr>
+</p:sld>
+</file>
+
+<file path=ppt/slides/slide8.xml><?xml version="1.0" encoding="utf-8"?>
+<p:sld xmlns:a="http://schemas.openxmlformats.org/drawingml/2006/main" xmlns:r="http://schemas.openxmlformats.org/officeDocument/2006/relationships" xmlns:p="http://schemas.openxmlformats.org/presentationml/2006/main">
+  <p:cSld>
+    <p:spTree>
+      <p:nvGrpSpPr>
+        <p:cNvPr id="1" name="">
+          <a:extLst>
+            <a:ext uri="{FF2B5EF4-FFF2-40B4-BE49-F238E27FC236}">
+              <a16:creationId xmlns:a16="http://schemas.microsoft.com/office/drawing/2014/main" id="{97A29453-3DA7-87C1-F867-7D137C707183}"/>
+            </a:ext>
+          </a:extLst>
+        </p:cNvPr>
+        <p:cNvGrpSpPr/>
+        <p:nvPr/>
+      </p:nvGrpSpPr>
+      <p:grpSpPr>
+        <a:xfrm>
+          <a:off x="0" y="0"/>
+          <a:ext cx="0" cy="0"/>
+          <a:chOff x="0" y="0"/>
+          <a:chExt cx="0" cy="0"/>
+        </a:xfrm>
+      </p:grpSpPr>
+      <p:sp>
+        <p:nvSpPr>
+          <p:cNvPr id="2" name="Title 1">
+            <a:extLst>
+              <a:ext uri="{FF2B5EF4-FFF2-40B4-BE49-F238E27FC236}">
+                <a16:creationId xmlns:a16="http://schemas.microsoft.com/office/drawing/2014/main" id="{CD7140C2-FB22-6D08-486A-04A981E351CD}"/>
+              </a:ext>
+            </a:extLst>
+          </p:cNvPr>
+          <p:cNvSpPr>
+            <a:spLocks noGrp="1"/>
+          </p:cNvSpPr>
+          <p:nvPr>
+            <p:ph type="title"/>
+          </p:nvPr>
+        </p:nvSpPr>
+        <p:spPr/>
+        <p:txBody>
+          <a:bodyPr>
+            <a:normAutofit/>
+          </a:bodyPr>
+          <a:lstStyle/>
+          <a:p>
+            <a:r>
+              <a:rPr lang="pt-BR" sz="2000" dirty="0"/>
+              <a:t>2026-03-15_MINI_BTCUSDT_1h_2021-01-01_2025-12-01_LB712_PRED12</a:t>
+            </a:r>
+            <a:endParaRPr lang="en-AT" sz="2000" dirty="0"/>
+          </a:p>
+        </p:txBody>
+      </p:sp>
+      <p:pic>
+        <p:nvPicPr>
+          <p:cNvPr id="7" name="Content Placeholder 6">
+            <a:extLst>
+              <a:ext uri="{FF2B5EF4-FFF2-40B4-BE49-F238E27FC236}">
+                <a16:creationId xmlns:a16="http://schemas.microsoft.com/office/drawing/2014/main" id="{5EE9E6DA-A520-647C-500E-6B6C8C10BCBE}"/>
+              </a:ext>
+            </a:extLst>
+          </p:cNvPr>
+          <p:cNvPicPr>
+            <a:picLocks noGrp="1" noChangeAspect="1"/>
+          </p:cNvPicPr>
+          <p:nvPr>
+            <p:ph idx="1"/>
+          </p:nvPr>
+        </p:nvPicPr>
+        <p:blipFill>
+          <a:blip r:embed="rId2"/>
+          <a:stretch>
+            <a:fillRect/>
+          </a:stretch>
+        </p:blipFill>
+        <p:spPr>
+          <a:xfrm>
+            <a:off x="838200" y="2281784"/>
+            <a:ext cx="10515600" cy="3439019"/>
+          </a:xfrm>
+          <a:prstGeom prst="rect">
+            <a:avLst/>
+          </a:prstGeom>
+        </p:spPr>
+      </p:pic>
+    </p:spTree>
+    <p:extLst>
+      <p:ext uri="{BB962C8B-B14F-4D97-AF65-F5344CB8AC3E}">
+        <p14:creationId xmlns:p14="http://schemas.microsoft.com/office/powerpoint/2010/main" val="736152415"/>
+      </p:ext>
+    </p:extLst>
+  </p:cSld>
+  <p:clrMapOvr>
+    <a:masterClrMapping/>
+  </p:clrMapOvr>
+</p:sld>
+</file>
+
+<file path=ppt/slides/slide9.xml><?xml version="1.0" encoding="utf-8"?>
+<p:sld xmlns:a="http://schemas.openxmlformats.org/drawingml/2006/main" xmlns:r="http://schemas.openxmlformats.org/officeDocument/2006/relationships" xmlns:p="http://schemas.openxmlformats.org/presentationml/2006/main">
+  <p:cSld>
+    <p:spTree>
+      <p:nvGrpSpPr>
+        <p:cNvPr id="1" name="">
+          <a:extLst>
+            <a:ext uri="{FF2B5EF4-FFF2-40B4-BE49-F238E27FC236}">
+              <a16:creationId xmlns:a16="http://schemas.microsoft.com/office/drawing/2014/main" id="{FC5CC8B4-78C3-CE32-715C-6A1B0D585947}"/>
+            </a:ext>
+          </a:extLst>
+        </p:cNvPr>
+        <p:cNvGrpSpPr/>
+        <p:nvPr/>
+      </p:nvGrpSpPr>
+      <p:grpSpPr>
+        <a:xfrm>
+          <a:off x="0" y="0"/>
+          <a:ext cx="0" cy="0"/>
+          <a:chOff x="0" y="0"/>
+          <a:chExt cx="0" cy="0"/>
+        </a:xfrm>
+      </p:grpSpPr>
+      <p:sp>
+        <p:nvSpPr>
+          <p:cNvPr id="2" name="Title 1">
+            <a:extLst>
+              <a:ext uri="{FF2B5EF4-FFF2-40B4-BE49-F238E27FC236}">
+                <a16:creationId xmlns:a16="http://schemas.microsoft.com/office/drawing/2014/main" id="{9E18AC7C-99FD-251F-412E-36E8A1721526}"/>
+              </a:ext>
+            </a:extLst>
+          </p:cNvPr>
+          <p:cNvSpPr>
+            <a:spLocks noGrp="1"/>
+          </p:cNvSpPr>
+          <p:nvPr>
+            <p:ph type="title"/>
+          </p:nvPr>
+        </p:nvSpPr>
+        <p:spPr/>
+        <p:txBody>
+          <a:bodyPr>
+            <a:normAutofit/>
+          </a:bodyPr>
+          <a:lstStyle/>
+          <a:p>
+            <a:r>
+              <a:rPr lang="pt-BR" sz="2000" dirty="0"/>
+              <a:t>2026-03-17_MINI_BTCUSDT_1h_2021-01-01_2025-12-01_LB400_PRED07</a:t>
+            </a:r>
+            <a:endParaRPr lang="en-AT" sz="2000" dirty="0"/>
+          </a:p>
+        </p:txBody>
+      </p:sp>
+      <p:pic>
+        <p:nvPicPr>
+          <p:cNvPr id="6" name="Content Placeholder 5">
+            <a:extLst>
+              <a:ext uri="{FF2B5EF4-FFF2-40B4-BE49-F238E27FC236}">
+                <a16:creationId xmlns:a16="http://schemas.microsoft.com/office/drawing/2014/main" id="{E6713B0A-D432-4055-D5E8-5BD9F54950A7}"/>
+              </a:ext>
+            </a:extLst>
+          </p:cNvPr>
+          <p:cNvPicPr>
+            <a:picLocks noGrp="1" noChangeAspect="1"/>
+          </p:cNvPicPr>
+          <p:nvPr>
+            <p:ph idx="1"/>
+          </p:nvPr>
+        </p:nvPicPr>
+        <p:blipFill>
+          <a:blip r:embed="rId2"/>
+          <a:stretch>
+            <a:fillRect/>
+          </a:stretch>
+        </p:blipFill>
+        <p:spPr>
+          <a:xfrm>
+            <a:off x="838200" y="2298363"/>
+            <a:ext cx="10515600" cy="3405862"/>
+          </a:xfrm>
+          <a:prstGeom prst="rect">
+            <a:avLst/>
+          </a:prstGeom>
+        </p:spPr>
+      </p:pic>
+    </p:spTree>
+    <p:extLst>
+      <p:ext uri="{BB962C8B-B14F-4D97-AF65-F5344CB8AC3E}">
+        <p14:creationId xmlns:p14="http://schemas.microsoft.com/office/powerpoint/2010/main" val="3446033242"/>
       </p:ext>
     </p:extLst>
   </p:cSld>

</xml_diff>